<commit_message>
feat(sih): add 5-stage interconnected workflow architecture and protocol connections pipeline to technical approach
</commit_message>
<xml_diff>
--- a/public/SIH2026_Digital_Twin_VARUNA_AI.pptx
+++ b/public/SIH2026_Digital_Twin_VARUNA_AI.pptx
@@ -2389,7 +2389,7 @@
                 <a:ea typeface="Arial Black" pitchFamily="34" charset="-122"/>
                 <a:cs typeface="Arial Black" pitchFamily="34" charset="-120"/>
               </a:rPr>
-              <a:t>TECHNICAL APPROACH</a:t>
+              <a:t>TECHNICAL APPROACH &amp; ARCHITECTURE WORKFLOW</a:t>
             </a:r>
             <a:endParaRPr lang="en-US" sz="2400" dirty="0"/>
           </a:p>
@@ -2475,261 +2475,1641 @@
       </p:sp>
       <p:sp>
         <p:nvSpPr>
-          <p:cNvPr id="6" name="Text 4"/>
-          <p:cNvSpPr/>
-          <p:nvPr/>
-        </p:nvSpPr>
-        <p:spPr>
-          <a:xfrm>
-            <a:off x="548640" y="1280160"/>
-            <a:ext cx="5669280" cy="320040"/>
-          </a:xfrm>
-          <a:prstGeom prst="rect">
-            <a:avLst/>
-          </a:prstGeom>
-          <a:noFill/>
-          <a:ln/>
-        </p:spPr>
-        <p:txBody>
-          <a:bodyPr wrap="square" rtlCol="0" anchor="ctr"/>
-          <a:lstStyle/>
-          <a:p>
-            <a:pPr indent="0" marL="0">
-              <a:buNone/>
-            </a:pPr>
-            <a:r>
-              <a:rPr lang="en-US" sz="1300" b="1" dirty="0">
-                <a:solidFill>
-                  <a:srgbClr val="0F172A"/>
+          <p:cNvPr id="6" name="Shape 4"/>
+          <p:cNvSpPr/>
+          <p:nvPr/>
+        </p:nvSpPr>
+        <p:spPr>
+          <a:xfrm>
+            <a:off x="548640" y="1234440"/>
+            <a:ext cx="2066544" cy="2514600"/>
+          </a:xfrm>
+          <a:prstGeom prst="roundRect">
+            <a:avLst>
+              <a:gd name="adj" fmla="val 3540"/>
+            </a:avLst>
+          </a:prstGeom>
+          <a:solidFill>
+            <a:srgbClr val="EFF6FF"/>
+          </a:solidFill>
+          <a:ln w="19050">
+            <a:solidFill>
+              <a:srgbClr val="BFDBFE"/>
+            </a:solidFill>
+            <a:prstDash val="solid"/>
+          </a:ln>
+        </p:spPr>
+      </p:sp>
+      <p:sp>
+        <p:nvSpPr>
+          <p:cNvPr id="7" name="Shape 5"/>
+          <p:cNvSpPr/>
+          <p:nvPr/>
+        </p:nvSpPr>
+        <p:spPr>
+          <a:xfrm>
+            <a:off x="640080" y="1325880"/>
+            <a:ext cx="594360" cy="228600"/>
+          </a:xfrm>
+          <a:prstGeom prst="roundRect">
+            <a:avLst>
+              <a:gd name="adj" fmla="val 20000"/>
+            </a:avLst>
+          </a:prstGeom>
+          <a:solidFill>
+            <a:srgbClr val="2563EB"/>
+          </a:solidFill>
+          <a:ln/>
+        </p:spPr>
+      </p:sp>
+      <p:sp>
+        <p:nvSpPr>
+          <p:cNvPr id="8" name="Text 6"/>
+          <p:cNvSpPr/>
+          <p:nvPr/>
+        </p:nvSpPr>
+        <p:spPr>
+          <a:xfrm>
+            <a:off x="640080" y="1325880"/>
+            <a:ext cx="594360" cy="228600"/>
+          </a:xfrm>
+          <a:prstGeom prst="rect">
+            <a:avLst/>
+          </a:prstGeom>
+          <a:noFill/>
+          <a:ln/>
+        </p:spPr>
+        <p:txBody>
+          <a:bodyPr wrap="square" rtlCol="0" anchor="ctr"/>
+          <a:lstStyle/>
+          <a:p>
+            <a:pPr algn="ctr" indent="0" marL="0">
+              <a:buNone/>
+            </a:pPr>
+            <a:r>
+              <a:rPr lang="en-US" sz="750" b="1" dirty="0">
+                <a:solidFill>
+                  <a:srgbClr val="FFFFFF"/>
                 </a:solidFill>
                 <a:latin typeface="Arial" pitchFamily="34" charset="0"/>
                 <a:ea typeface="Arial" pitchFamily="34" charset="-122"/>
                 <a:cs typeface="Arial" pitchFamily="34" charset="-120"/>
               </a:rPr>
-              <a:t>Technologies to be used:</a:t>
-            </a:r>
-            <a:endParaRPr lang="en-US" sz="1300" dirty="0"/>
-          </a:p>
-        </p:txBody>
-      </p:sp>
-      <p:sp>
-        <p:nvSpPr>
-          <p:cNvPr id="7" name="Text 5"/>
-          <p:cNvSpPr/>
-          <p:nvPr/>
-        </p:nvSpPr>
-        <p:spPr>
-          <a:xfrm>
-            <a:off x="548640" y="1645920"/>
-            <a:ext cx="5669280" cy="2103120"/>
-          </a:xfrm>
-          <a:prstGeom prst="rect">
-            <a:avLst/>
-          </a:prstGeom>
-          <a:noFill/>
-          <a:ln/>
-        </p:spPr>
-        <p:txBody>
-          <a:bodyPr wrap="square" rtlCol="0" anchor="ctr"/>
-          <a:lstStyle/>
-          <a:p>
-            <a:pPr indent="0" marL="0">
-              <a:buNone/>
-            </a:pPr>
-            <a:r>
-              <a:rPr lang="en-US" sz="1100" b="1" dirty="0">
-                <a:solidFill>
-                  <a:srgbClr val="0F172A"/>
-                </a:solidFill>
-                <a:latin typeface="Calibri" pitchFamily="34" charset="0"/>
-                <a:ea typeface="Calibri" pitchFamily="34" charset="-122"/>
-                <a:cs typeface="Calibri" pitchFamily="34" charset="-120"/>
-              </a:rPr>
-              <a:t>• Edge &amp; SCADA Hardware: </a:t>
-            </a:r>
-            <a:pPr indent="0" marL="0">
-              <a:buNone/>
-            </a:pPr>
-            <a:r>
-              <a:rPr lang="en-US" sz="1100" dirty="0">
-                <a:solidFill>
-                  <a:srgbClr val="334155"/>
-                </a:solidFill>
-                <a:latin typeface="Calibri" pitchFamily="34" charset="0"/>
-                <a:ea typeface="Calibri" pitchFamily="34" charset="-122"/>
-                <a:cs typeface="Calibri" pitchFamily="34" charset="-120"/>
-              </a:rPr>
-              <a:t>Wellhead PLCs, MPFM Coriolis meters, PDC torque load cells, Serial USB / Modbus.
-</a:t>
-            </a:r>
-            <a:pPr indent="0" marL="0">
-              <a:buNone/>
-            </a:pPr>
-            <a:r>
-              <a:rPr lang="en-US" sz="1100" b="1" dirty="0">
-                <a:solidFill>
-                  <a:srgbClr val="0F172A"/>
-                </a:solidFill>
-                <a:latin typeface="Calibri" pitchFamily="34" charset="0"/>
-                <a:ea typeface="Calibri" pitchFamily="34" charset="-122"/>
-                <a:cs typeface="Calibri" pitchFamily="34" charset="-120"/>
-              </a:rPr>
-              <a:t>• Physics Engines: </a:t>
-            </a:r>
-            <a:pPr indent="0" marL="0">
-              <a:buNone/>
-            </a:pPr>
-            <a:r>
-              <a:rPr lang="en-US" sz="1100" dirty="0">
-                <a:solidFill>
-                  <a:srgbClr val="334155"/>
-                </a:solidFill>
-                <a:latin typeface="Calibri" pitchFamily="34" charset="0"/>
-                <a:ea typeface="Calibri" pitchFamily="34" charset="-122"/>
-                <a:cs typeface="Calibri" pitchFamily="34" charset="-120"/>
-              </a:rPr>
-              <a:t>ASTM D1250 / API MPMS 11.1, Darcy-Weisbach flow hydraulics, Coriolis resonant density.
-</a:t>
-            </a:r>
-            <a:pPr indent="0" marL="0">
-              <a:buNone/>
-            </a:pPr>
-            <a:r>
-              <a:rPr lang="en-US" sz="1100" b="1" dirty="0">
-                <a:solidFill>
-                  <a:srgbClr val="0F172A"/>
-                </a:solidFill>
-                <a:latin typeface="Calibri" pitchFamily="34" charset="0"/>
-                <a:ea typeface="Calibri" pitchFamily="34" charset="-122"/>
-                <a:cs typeface="Calibri" pitchFamily="34" charset="-120"/>
-              </a:rPr>
-              <a:t>• AI &amp; Signal Processing: </a:t>
-            </a:r>
-            <a:pPr indent="0" marL="0">
-              <a:buNone/>
-            </a:pPr>
-            <a:r>
-              <a:rPr lang="en-US" sz="1100" dirty="0">
-                <a:solidFill>
-                  <a:srgbClr val="334155"/>
-                </a:solidFill>
-                <a:latin typeface="Calibri" pitchFamily="34" charset="0"/>
-                <a:ea typeface="Calibri" pitchFamily="34" charset="-122"/>
-                <a:cs typeface="Calibri" pitchFamily="34" charset="-120"/>
-              </a:rPr>
-              <a:t>1D Kalman state estimators, XGBoost stick-slip anomaly classifiers.
-</a:t>
-            </a:r>
-            <a:pPr indent="0" marL="0">
-              <a:buNone/>
-            </a:pPr>
-            <a:r>
-              <a:rPr lang="en-US" sz="1100" b="1" dirty="0">
-                <a:solidFill>
-                  <a:srgbClr val="0F172A"/>
-                </a:solidFill>
-                <a:latin typeface="Calibri" pitchFamily="34" charset="0"/>
-                <a:ea typeface="Calibri" pitchFamily="34" charset="-122"/>
-                <a:cs typeface="Calibri" pitchFamily="34" charset="-120"/>
-              </a:rPr>
-              <a:t>• 3D Spatial Interface: </a:t>
-            </a:r>
-            <a:pPr indent="0" marL="0">
-              <a:buNone/>
-            </a:pPr>
-            <a:r>
-              <a:rPr lang="en-US" sz="1100" dirty="0">
-                <a:solidFill>
-                  <a:srgbClr val="334155"/>
-                </a:solidFill>
-                <a:latin typeface="Calibri" pitchFamily="34" charset="0"/>
-                <a:ea typeface="Calibri" pitchFamily="34" charset="-122"/>
-                <a:cs typeface="Calibri" pitchFamily="34" charset="-120"/>
-              </a:rPr>
-              <a:t>React Three Fiber / Three.js WebGL with real-time gesture &amp; voice HUD.
-</a:t>
-            </a:r>
-            <a:pPr indent="0" marL="0">
-              <a:buNone/>
-            </a:pPr>
-            <a:r>
-              <a:rPr lang="en-US" sz="1100" b="1" dirty="0">
-                <a:solidFill>
-                  <a:srgbClr val="0F172A"/>
-                </a:solidFill>
-                <a:latin typeface="Calibri" pitchFamily="34" charset="0"/>
-                <a:ea typeface="Calibri" pitchFamily="34" charset="-122"/>
-                <a:cs typeface="Calibri" pitchFamily="34" charset="-120"/>
-              </a:rPr>
-              <a:t>• Local Database Engine: </a:t>
-            </a:r>
-            <a:pPr indent="0" marL="0">
-              <a:buNone/>
-            </a:pPr>
-            <a:r>
-              <a:rPr lang="en-US" sz="1100" dirty="0">
-                <a:solidFill>
-                  <a:srgbClr val="334155"/>
-                </a:solidFill>
-                <a:latin typeface="Calibri" pitchFamily="34" charset="0"/>
-                <a:ea typeface="Calibri" pitchFamily="34" charset="-122"/>
-                <a:cs typeface="Calibri" pitchFamily="34" charset="-120"/>
-              </a:rPr>
-              <a:t>IndexedDB &amp; time-series binary search ledger (&lt;0.1ms query latency).</a:t>
-            </a:r>
-            <a:endParaRPr lang="en-US" sz="1100" dirty="0"/>
-          </a:p>
-        </p:txBody>
-      </p:sp>
-      <p:sp>
-        <p:nvSpPr>
-          <p:cNvPr id="8" name="Text 6"/>
-          <p:cNvSpPr/>
-          <p:nvPr/>
-        </p:nvSpPr>
-        <p:spPr>
-          <a:xfrm>
-            <a:off x="548640" y="3886200"/>
-            <a:ext cx="5669280" cy="320040"/>
-          </a:xfrm>
-          <a:prstGeom prst="rect">
-            <a:avLst/>
-          </a:prstGeom>
-          <a:noFill/>
-          <a:ln/>
-        </p:spPr>
-        <p:txBody>
-          <a:bodyPr wrap="square" rtlCol="0" anchor="ctr"/>
-          <a:lstStyle/>
-          <a:p>
-            <a:pPr indent="0" marL="0">
-              <a:buNone/>
-            </a:pPr>
-            <a:r>
-              <a:rPr lang="en-US" sz="1300" b="1" dirty="0">
-                <a:solidFill>
-                  <a:srgbClr val="0F172A"/>
+              <a:t>STAGE 01</a:t>
+            </a:r>
+            <a:endParaRPr lang="en-US" sz="750" dirty="0"/>
+          </a:p>
+        </p:txBody>
+      </p:sp>
+      <p:sp>
+        <p:nvSpPr>
+          <p:cNvPr id="9" name="Text 7"/>
+          <p:cNvSpPr/>
+          <p:nvPr/>
+        </p:nvSpPr>
+        <p:spPr>
+          <a:xfrm>
+            <a:off x="1280160" y="1344168"/>
+            <a:ext cx="1243584" cy="201168"/>
+          </a:xfrm>
+          <a:prstGeom prst="rect">
+            <a:avLst/>
+          </a:prstGeom>
+          <a:noFill/>
+          <a:ln/>
+        </p:spPr>
+        <p:txBody>
+          <a:bodyPr wrap="square" rtlCol="0" anchor="ctr"/>
+          <a:lstStyle/>
+          <a:p>
+            <a:pPr indent="0" marL="0">
+              <a:buNone/>
+            </a:pPr>
+            <a:r>
+              <a:rPr lang="en-US" sz="700" b="1" dirty="0">
+                <a:solidFill>
+                  <a:srgbClr val="64748B"/>
                 </a:solidFill>
                 <a:latin typeface="Arial" pitchFamily="34" charset="0"/>
                 <a:ea typeface="Arial" pitchFamily="34" charset="-122"/>
                 <a:cs typeface="Arial" pitchFamily="34" charset="-120"/>
               </a:rPr>
-              <a:t>Methodology and process for implementation:</a:t>
-            </a:r>
-            <a:endParaRPr lang="en-US" sz="1300" dirty="0"/>
-          </a:p>
-        </p:txBody>
-      </p:sp>
-      <p:sp>
-        <p:nvSpPr>
-          <p:cNvPr id="9" name="Text 7"/>
-          <p:cNvSpPr/>
-          <p:nvPr/>
-        </p:nvSpPr>
-        <p:spPr>
-          <a:xfrm>
-            <a:off x="548640" y="4251960"/>
-            <a:ext cx="5669280" cy="1920240"/>
+              <a:t>DATA ACQUISITION</a:t>
+            </a:r>
+            <a:endParaRPr lang="en-US" sz="700" dirty="0"/>
+          </a:p>
+        </p:txBody>
+      </p:sp>
+      <p:sp>
+        <p:nvSpPr>
+          <p:cNvPr id="10" name="Text 8"/>
+          <p:cNvSpPr/>
+          <p:nvPr/>
+        </p:nvSpPr>
+        <p:spPr>
+          <a:xfrm>
+            <a:off x="640080" y="1581912"/>
+            <a:ext cx="1883664" cy="384048"/>
+          </a:xfrm>
+          <a:prstGeom prst="rect">
+            <a:avLst/>
+          </a:prstGeom>
+          <a:noFill/>
+          <a:ln/>
+        </p:spPr>
+        <p:txBody>
+          <a:bodyPr wrap="square" rtlCol="0" anchor="ctr"/>
+          <a:lstStyle/>
+          <a:p>
+            <a:pPr indent="0" marL="0">
+              <a:buNone/>
+            </a:pPr>
+            <a:r>
+              <a:rPr lang="en-US" sz="950" b="1" dirty="0">
+                <a:solidFill>
+                  <a:srgbClr val="1E3A8A"/>
+                </a:solidFill>
+                <a:latin typeface="Arial" pitchFamily="34" charset="0"/>
+                <a:ea typeface="Arial" pitchFamily="34" charset="-122"/>
+                <a:cs typeface="Arial" pitchFamily="34" charset="-120"/>
+              </a:rPr>
+              <a:t>EDGE SENSORS &amp; SCADA</a:t>
+            </a:r>
+            <a:endParaRPr lang="en-US" sz="950" dirty="0"/>
+          </a:p>
+        </p:txBody>
+      </p:sp>
+      <p:sp>
+        <p:nvSpPr>
+          <p:cNvPr id="11" name="Text 9"/>
+          <p:cNvSpPr/>
+          <p:nvPr/>
+        </p:nvSpPr>
+        <p:spPr>
+          <a:xfrm>
+            <a:off x="640080" y="1984248"/>
+            <a:ext cx="1883664" cy="1325880"/>
+          </a:xfrm>
+          <a:prstGeom prst="rect">
+            <a:avLst/>
+          </a:prstGeom>
+          <a:noFill/>
+          <a:ln/>
+        </p:spPr>
+        <p:txBody>
+          <a:bodyPr wrap="square" rtlCol="0" anchor="ctr"/>
+          <a:lstStyle/>
+          <a:p>
+            <a:pPr indent="0" marL="0">
+              <a:buNone/>
+            </a:pPr>
+            <a:r>
+              <a:rPr lang="en-US" sz="800" dirty="0">
+                <a:solidFill>
+                  <a:srgbClr val="334155"/>
+                </a:solidFill>
+                <a:latin typeface="Calibri" pitchFamily="34" charset="0"/>
+                <a:ea typeface="Calibri" pitchFamily="34" charset="-122"/>
+                <a:cs typeface="Calibri" pitchFamily="34" charset="-120"/>
+              </a:rPr>
+              <a:t>• Subsea X-Mas Tree Gauges (P, T)</a:t>
+            </a:r>
+            <a:endParaRPr lang="en-US" sz="800" dirty="0"/>
+          </a:p>
+          <a:p>
+            <a:pPr indent="0" marL="0">
+              <a:buNone/>
+            </a:pPr>
+            <a:r>
+              <a:rPr lang="en-US" sz="800" dirty="0">
+                <a:solidFill>
+                  <a:srgbClr val="334155"/>
+                </a:solidFill>
+                <a:latin typeface="Calibri" pitchFamily="34" charset="0"/>
+                <a:ea typeface="Calibri" pitchFamily="34" charset="-122"/>
+                <a:cs typeface="Calibri" pitchFamily="34" charset="-120"/>
+              </a:rPr>
+              <a:t>• PDC Drill Core (WOB, Torque)</a:t>
+            </a:r>
+            <a:endParaRPr lang="en-US" sz="800" dirty="0"/>
+          </a:p>
+          <a:p>
+            <a:pPr indent="0" marL="0">
+              <a:buNone/>
+            </a:pPr>
+            <a:r>
+              <a:rPr lang="en-US" sz="800" dirty="0">
+                <a:solidFill>
+                  <a:srgbClr val="334155"/>
+                </a:solidFill>
+                <a:latin typeface="Calibri" pitchFamily="34" charset="0"/>
+                <a:ea typeface="Calibri" pitchFamily="34" charset="-122"/>
+                <a:cs typeface="Calibri" pitchFamily="34" charset="-120"/>
+              </a:rPr>
+              <a:t>• Topside MPFM Coriolis Meters</a:t>
+            </a:r>
+            <a:endParaRPr lang="en-US" sz="800" dirty="0"/>
+          </a:p>
+          <a:p>
+            <a:pPr indent="0" marL="0">
+              <a:buNone/>
+            </a:pPr>
+            <a:r>
+              <a:rPr lang="en-US" sz="800" dirty="0">
+                <a:solidFill>
+                  <a:srgbClr val="334155"/>
+                </a:solidFill>
+                <a:latin typeface="Calibri" pitchFamily="34" charset="0"/>
+                <a:ea typeface="Calibri" pitchFamily="34" charset="-122"/>
+                <a:cs typeface="Calibri" pitchFamily="34" charset="-120"/>
+              </a:rPr>
+              <a:t>• 50.0 Hz (20ms) Telemetry Stream</a:t>
+            </a:r>
+            <a:endParaRPr lang="en-US" sz="800" dirty="0"/>
+          </a:p>
+        </p:txBody>
+      </p:sp>
+      <p:sp>
+        <p:nvSpPr>
+          <p:cNvPr id="12" name="Shape 10"/>
+          <p:cNvSpPr/>
+          <p:nvPr/>
+        </p:nvSpPr>
+        <p:spPr>
+          <a:xfrm>
+            <a:off x="594360" y="3401568"/>
+            <a:ext cx="1975104" cy="274320"/>
+          </a:xfrm>
+          <a:prstGeom prst="rect">
+            <a:avLst/>
+          </a:prstGeom>
+          <a:solidFill>
+            <a:srgbClr val="FFFFFF"/>
+          </a:solidFill>
+          <a:ln w="12700">
+            <a:solidFill>
+              <a:srgbClr val="BFDBFE"/>
+            </a:solidFill>
+            <a:prstDash val="solid"/>
+          </a:ln>
+        </p:spPr>
+      </p:sp>
+      <p:sp>
+        <p:nvSpPr>
+          <p:cNvPr id="13" name="Text 11"/>
+          <p:cNvSpPr/>
+          <p:nvPr/>
+        </p:nvSpPr>
+        <p:spPr>
+          <a:xfrm>
+            <a:off x="594360" y="3401568"/>
+            <a:ext cx="1975104" cy="274320"/>
+          </a:xfrm>
+          <a:prstGeom prst="rect">
+            <a:avLst/>
+          </a:prstGeom>
+          <a:noFill/>
+          <a:ln/>
+        </p:spPr>
+        <p:txBody>
+          <a:bodyPr wrap="square" rtlCol="0" anchor="ctr"/>
+          <a:lstStyle/>
+          <a:p>
+            <a:pPr algn="ctr" indent="0" marL="0">
+              <a:buNone/>
+            </a:pPr>
+            <a:r>
+              <a:rPr lang="en-US" sz="750" b="1" dirty="0">
+                <a:solidFill>
+                  <a:srgbClr val="1E3A8A"/>
+                </a:solidFill>
+                <a:latin typeface="Arial" pitchFamily="34" charset="0"/>
+                <a:ea typeface="Arial" pitchFamily="34" charset="-122"/>
+                <a:cs typeface="Arial" pitchFamily="34" charset="-120"/>
+              </a:rPr>
+              <a:t>Modbus / OPC-UA / WITSML ➔</a:t>
+            </a:r>
+            <a:endParaRPr lang="en-US" sz="750" dirty="0"/>
+          </a:p>
+        </p:txBody>
+      </p:sp>
+      <p:sp>
+        <p:nvSpPr>
+          <p:cNvPr id="14" name="Shape 12"/>
+          <p:cNvSpPr/>
+          <p:nvPr/>
+        </p:nvSpPr>
+        <p:spPr>
+          <a:xfrm>
+            <a:off x="2816352" y="1234440"/>
+            <a:ext cx="2066544" cy="2514600"/>
+          </a:xfrm>
+          <a:prstGeom prst="roundRect">
+            <a:avLst>
+              <a:gd name="adj" fmla="val 3540"/>
+            </a:avLst>
+          </a:prstGeom>
+          <a:solidFill>
+            <a:srgbClr val="F0FDF4"/>
+          </a:solidFill>
+          <a:ln w="19050">
+            <a:solidFill>
+              <a:srgbClr val="BBF7D0"/>
+            </a:solidFill>
+            <a:prstDash val="solid"/>
+          </a:ln>
+        </p:spPr>
+      </p:sp>
+      <p:sp>
+        <p:nvSpPr>
+          <p:cNvPr id="15" name="Shape 13"/>
+          <p:cNvSpPr/>
+          <p:nvPr/>
+        </p:nvSpPr>
+        <p:spPr>
+          <a:xfrm>
+            <a:off x="2907792" y="1325880"/>
+            <a:ext cx="594360" cy="228600"/>
+          </a:xfrm>
+          <a:prstGeom prst="roundRect">
+            <a:avLst>
+              <a:gd name="adj" fmla="val 20000"/>
+            </a:avLst>
+          </a:prstGeom>
+          <a:solidFill>
+            <a:srgbClr val="059669"/>
+          </a:solidFill>
+          <a:ln/>
+        </p:spPr>
+      </p:sp>
+      <p:sp>
+        <p:nvSpPr>
+          <p:cNvPr id="16" name="Text 14"/>
+          <p:cNvSpPr/>
+          <p:nvPr/>
+        </p:nvSpPr>
+        <p:spPr>
+          <a:xfrm>
+            <a:off x="2907792" y="1325880"/>
+            <a:ext cx="594360" cy="228600"/>
+          </a:xfrm>
+          <a:prstGeom prst="rect">
+            <a:avLst/>
+          </a:prstGeom>
+          <a:noFill/>
+          <a:ln/>
+        </p:spPr>
+        <p:txBody>
+          <a:bodyPr wrap="square" rtlCol="0" anchor="ctr"/>
+          <a:lstStyle/>
+          <a:p>
+            <a:pPr algn="ctr" indent="0" marL="0">
+              <a:buNone/>
+            </a:pPr>
+            <a:r>
+              <a:rPr lang="en-US" sz="750" b="1" dirty="0">
+                <a:solidFill>
+                  <a:srgbClr val="FFFFFF"/>
+                </a:solidFill>
+                <a:latin typeface="Arial" pitchFamily="34" charset="0"/>
+                <a:ea typeface="Arial" pitchFamily="34" charset="-122"/>
+                <a:cs typeface="Arial" pitchFamily="34" charset="-120"/>
+              </a:rPr>
+              <a:t>STAGE 02</a:t>
+            </a:r>
+            <a:endParaRPr lang="en-US" sz="750" dirty="0"/>
+          </a:p>
+        </p:txBody>
+      </p:sp>
+      <p:sp>
+        <p:nvSpPr>
+          <p:cNvPr id="17" name="Text 15"/>
+          <p:cNvSpPr/>
+          <p:nvPr/>
+        </p:nvSpPr>
+        <p:spPr>
+          <a:xfrm>
+            <a:off x="3547872" y="1344168"/>
+            <a:ext cx="1243584" cy="201168"/>
+          </a:xfrm>
+          <a:prstGeom prst="rect">
+            <a:avLst/>
+          </a:prstGeom>
+          <a:noFill/>
+          <a:ln/>
+        </p:spPr>
+        <p:txBody>
+          <a:bodyPr wrap="square" rtlCol="0" anchor="ctr"/>
+          <a:lstStyle/>
+          <a:p>
+            <a:pPr indent="0" marL="0">
+              <a:buNone/>
+            </a:pPr>
+            <a:r>
+              <a:rPr lang="en-US" sz="700" b="1" dirty="0">
+                <a:solidFill>
+                  <a:srgbClr val="64748B"/>
+                </a:solidFill>
+                <a:latin typeface="Arial" pitchFamily="34" charset="0"/>
+                <a:ea typeface="Arial" pitchFamily="34" charset="-122"/>
+                <a:cs typeface="Arial" pitchFamily="34" charset="-120"/>
+              </a:rPr>
+              <a:t>SIGNAL CONDITIONING</a:t>
+            </a:r>
+            <a:endParaRPr lang="en-US" sz="700" dirty="0"/>
+          </a:p>
+        </p:txBody>
+      </p:sp>
+      <p:sp>
+        <p:nvSpPr>
+          <p:cNvPr id="18" name="Text 16"/>
+          <p:cNvSpPr/>
+          <p:nvPr/>
+        </p:nvSpPr>
+        <p:spPr>
+          <a:xfrm>
+            <a:off x="2907792" y="1581912"/>
+            <a:ext cx="1883664" cy="384048"/>
+          </a:xfrm>
+          <a:prstGeom prst="rect">
+            <a:avLst/>
+          </a:prstGeom>
+          <a:noFill/>
+          <a:ln/>
+        </p:spPr>
+        <p:txBody>
+          <a:bodyPr wrap="square" rtlCol="0" anchor="ctr"/>
+          <a:lstStyle/>
+          <a:p>
+            <a:pPr indent="0" marL="0">
+              <a:buNone/>
+            </a:pPr>
+            <a:r>
+              <a:rPr lang="en-US" sz="950" b="1" dirty="0">
+                <a:solidFill>
+                  <a:srgbClr val="065F46"/>
+                </a:solidFill>
+                <a:latin typeface="Arial" pitchFamily="34" charset="0"/>
+                <a:ea typeface="Arial" pitchFamily="34" charset="-122"/>
+                <a:cs typeface="Arial" pitchFamily="34" charset="-120"/>
+              </a:rPr>
+              <a:t>DENOISING &amp; INGESTION</a:t>
+            </a:r>
+            <a:endParaRPr lang="en-US" sz="950" dirty="0"/>
+          </a:p>
+        </p:txBody>
+      </p:sp>
+      <p:sp>
+        <p:nvSpPr>
+          <p:cNvPr id="19" name="Text 17"/>
+          <p:cNvSpPr/>
+          <p:nvPr/>
+        </p:nvSpPr>
+        <p:spPr>
+          <a:xfrm>
+            <a:off x="2907792" y="1984248"/>
+            <a:ext cx="1883664" cy="1325880"/>
+          </a:xfrm>
+          <a:prstGeom prst="rect">
+            <a:avLst/>
+          </a:prstGeom>
+          <a:noFill/>
+          <a:ln/>
+        </p:spPr>
+        <p:txBody>
+          <a:bodyPr wrap="square" rtlCol="0" anchor="ctr"/>
+          <a:lstStyle/>
+          <a:p>
+            <a:pPr indent="0" marL="0">
+              <a:buNone/>
+            </a:pPr>
+            <a:r>
+              <a:rPr lang="en-US" sz="800" dirty="0">
+                <a:solidFill>
+                  <a:srgbClr val="334155"/>
+                </a:solidFill>
+                <a:latin typeface="Calibri" pitchFamily="34" charset="0"/>
+                <a:ea typeface="Calibri" pitchFamily="34" charset="-122"/>
+                <a:cs typeface="Calibri" pitchFamily="34" charset="-120"/>
+              </a:rPr>
+              <a:t>• 1D Kalman Noise Filtering</a:t>
+            </a:r>
+            <a:endParaRPr lang="en-US" sz="800" dirty="0"/>
+          </a:p>
+          <a:p>
+            <a:pPr indent="0" marL="0">
+              <a:buNone/>
+            </a:pPr>
+            <a:r>
+              <a:rPr lang="en-US" sz="800" dirty="0">
+                <a:solidFill>
+                  <a:srgbClr val="334155"/>
+                </a:solidFill>
+                <a:latin typeface="Calibri" pitchFamily="34" charset="0"/>
+                <a:ea typeface="Calibri" pitchFamily="34" charset="-122"/>
+                <a:cs typeface="Calibri" pitchFamily="34" charset="-120"/>
+              </a:rPr>
+              <a:t>• Recursive Bayesian Estimator</a:t>
+            </a:r>
+            <a:endParaRPr lang="en-US" sz="800" dirty="0"/>
+          </a:p>
+          <a:p>
+            <a:pPr indent="0" marL="0">
+              <a:buNone/>
+            </a:pPr>
+            <a:r>
+              <a:rPr lang="en-US" sz="800" dirty="0">
+                <a:solidFill>
+                  <a:srgbClr val="334155"/>
+                </a:solidFill>
+                <a:latin typeface="Calibri" pitchFamily="34" charset="0"/>
+                <a:ea typeface="Calibri" pitchFamily="34" charset="-122"/>
+                <a:cs typeface="Calibri" pitchFamily="34" charset="-120"/>
+              </a:rPr>
+              <a:t>• Multi-Rate Synchronizer</a:t>
+            </a:r>
+            <a:endParaRPr lang="en-US" sz="800" dirty="0"/>
+          </a:p>
+          <a:p>
+            <a:pPr indent="0" marL="0">
+              <a:buNone/>
+            </a:pPr>
+            <a:r>
+              <a:rPr lang="en-US" sz="800" dirty="0">
+                <a:solidFill>
+                  <a:srgbClr val="334155"/>
+                </a:solidFill>
+                <a:latin typeface="Calibri" pitchFamily="34" charset="0"/>
+                <a:ea typeface="Calibri" pitchFamily="34" charset="-122"/>
+                <a:cs typeface="Calibri" pitchFamily="34" charset="-120"/>
+              </a:rPr>
+              <a:t>• 180-Day Time-Series Ledger</a:t>
+            </a:r>
+            <a:endParaRPr lang="en-US" sz="800" dirty="0"/>
+          </a:p>
+        </p:txBody>
+      </p:sp>
+      <p:sp>
+        <p:nvSpPr>
+          <p:cNvPr id="20" name="Shape 18"/>
+          <p:cNvSpPr/>
+          <p:nvPr/>
+        </p:nvSpPr>
+        <p:spPr>
+          <a:xfrm>
+            <a:off x="2862072" y="3401568"/>
+            <a:ext cx="1975104" cy="274320"/>
+          </a:xfrm>
+          <a:prstGeom prst="rect">
+            <a:avLst/>
+          </a:prstGeom>
+          <a:solidFill>
+            <a:srgbClr val="FFFFFF"/>
+          </a:solidFill>
+          <a:ln w="12700">
+            <a:solidFill>
+              <a:srgbClr val="BBF7D0"/>
+            </a:solidFill>
+            <a:prstDash val="solid"/>
+          </a:ln>
+        </p:spPr>
+      </p:sp>
+      <p:sp>
+        <p:nvSpPr>
+          <p:cNvPr id="21" name="Text 19"/>
+          <p:cNvSpPr/>
+          <p:nvPr/>
+        </p:nvSpPr>
+        <p:spPr>
+          <a:xfrm>
+            <a:off x="2862072" y="3401568"/>
+            <a:ext cx="1975104" cy="274320"/>
+          </a:xfrm>
+          <a:prstGeom prst="rect">
+            <a:avLst/>
+          </a:prstGeom>
+          <a:noFill/>
+          <a:ln/>
+        </p:spPr>
+        <p:txBody>
+          <a:bodyPr wrap="square" rtlCol="0" anchor="ctr"/>
+          <a:lstStyle/>
+          <a:p>
+            <a:pPr algn="ctr" indent="0" marL="0">
+              <a:buNone/>
+            </a:pPr>
+            <a:r>
+              <a:rPr lang="en-US" sz="750" b="1" dirty="0">
+                <a:solidFill>
+                  <a:srgbClr val="065F46"/>
+                </a:solidFill>
+                <a:latin typeface="Arial" pitchFamily="34" charset="0"/>
+                <a:ea typeface="Arial" pitchFamily="34" charset="-122"/>
+                <a:cs typeface="Arial" pitchFamily="34" charset="-120"/>
+              </a:rPr>
+              <a:t>Filtered State Stream ➔</a:t>
+            </a:r>
+            <a:endParaRPr lang="en-US" sz="750" dirty="0"/>
+          </a:p>
+        </p:txBody>
+      </p:sp>
+      <p:sp>
+        <p:nvSpPr>
+          <p:cNvPr id="22" name="Shape 20"/>
+          <p:cNvSpPr/>
+          <p:nvPr/>
+        </p:nvSpPr>
+        <p:spPr>
+          <a:xfrm>
+            <a:off x="5084064" y="1234440"/>
+            <a:ext cx="2066544" cy="2514600"/>
+          </a:xfrm>
+          <a:prstGeom prst="roundRect">
+            <a:avLst>
+              <a:gd name="adj" fmla="val 3540"/>
+            </a:avLst>
+          </a:prstGeom>
+          <a:solidFill>
+            <a:srgbClr val="FFFBEB"/>
+          </a:solidFill>
+          <a:ln w="19050">
+            <a:solidFill>
+              <a:srgbClr val="FDE68A"/>
+            </a:solidFill>
+            <a:prstDash val="solid"/>
+          </a:ln>
+        </p:spPr>
+      </p:sp>
+      <p:sp>
+        <p:nvSpPr>
+          <p:cNvPr id="23" name="Shape 21"/>
+          <p:cNvSpPr/>
+          <p:nvPr/>
+        </p:nvSpPr>
+        <p:spPr>
+          <a:xfrm>
+            <a:off x="5175504" y="1325880"/>
+            <a:ext cx="594360" cy="228600"/>
+          </a:xfrm>
+          <a:prstGeom prst="roundRect">
+            <a:avLst>
+              <a:gd name="adj" fmla="val 20000"/>
+            </a:avLst>
+          </a:prstGeom>
+          <a:solidFill>
+            <a:srgbClr val="D97706"/>
+          </a:solidFill>
+          <a:ln/>
+        </p:spPr>
+      </p:sp>
+      <p:sp>
+        <p:nvSpPr>
+          <p:cNvPr id="24" name="Text 22"/>
+          <p:cNvSpPr/>
+          <p:nvPr/>
+        </p:nvSpPr>
+        <p:spPr>
+          <a:xfrm>
+            <a:off x="5175504" y="1325880"/>
+            <a:ext cx="594360" cy="228600"/>
+          </a:xfrm>
+          <a:prstGeom prst="rect">
+            <a:avLst/>
+          </a:prstGeom>
+          <a:noFill/>
+          <a:ln/>
+        </p:spPr>
+        <p:txBody>
+          <a:bodyPr wrap="square" rtlCol="0" anchor="ctr"/>
+          <a:lstStyle/>
+          <a:p>
+            <a:pPr algn="ctr" indent="0" marL="0">
+              <a:buNone/>
+            </a:pPr>
+            <a:r>
+              <a:rPr lang="en-US" sz="750" b="1" dirty="0">
+                <a:solidFill>
+                  <a:srgbClr val="FFFFFF"/>
+                </a:solidFill>
+                <a:latin typeface="Arial" pitchFamily="34" charset="0"/>
+                <a:ea typeface="Arial" pitchFamily="34" charset="-122"/>
+                <a:cs typeface="Arial" pitchFamily="34" charset="-120"/>
+              </a:rPr>
+              <a:t>STAGE 03</a:t>
+            </a:r>
+            <a:endParaRPr lang="en-US" sz="750" dirty="0"/>
+          </a:p>
+        </p:txBody>
+      </p:sp>
+      <p:sp>
+        <p:nvSpPr>
+          <p:cNvPr id="25" name="Text 23"/>
+          <p:cNvSpPr/>
+          <p:nvPr/>
+        </p:nvSpPr>
+        <p:spPr>
+          <a:xfrm>
+            <a:off x="5815584" y="1344168"/>
+            <a:ext cx="1243584" cy="201168"/>
+          </a:xfrm>
+          <a:prstGeom prst="rect">
+            <a:avLst/>
+          </a:prstGeom>
+          <a:noFill/>
+          <a:ln/>
+        </p:spPr>
+        <p:txBody>
+          <a:bodyPr wrap="square" rtlCol="0" anchor="ctr"/>
+          <a:lstStyle/>
+          <a:p>
+            <a:pPr indent="0" marL="0">
+              <a:buNone/>
+            </a:pPr>
+            <a:r>
+              <a:rPr lang="en-US" sz="700" b="1" dirty="0">
+                <a:solidFill>
+                  <a:srgbClr val="64748B"/>
+                </a:solidFill>
+                <a:latin typeface="Arial" pitchFamily="34" charset="0"/>
+                <a:ea typeface="Arial" pitchFamily="34" charset="-122"/>
+                <a:cs typeface="Arial" pitchFamily="34" charset="-120"/>
+              </a:rPr>
+              <a:t>ANALYTICAL PROCESSING</a:t>
+            </a:r>
+            <a:endParaRPr lang="en-US" sz="700" dirty="0"/>
+          </a:p>
+        </p:txBody>
+      </p:sp>
+      <p:sp>
+        <p:nvSpPr>
+          <p:cNvPr id="26" name="Text 24"/>
+          <p:cNvSpPr/>
+          <p:nvPr/>
+        </p:nvSpPr>
+        <p:spPr>
+          <a:xfrm>
+            <a:off x="5175504" y="1581912"/>
+            <a:ext cx="1883664" cy="384048"/>
+          </a:xfrm>
+          <a:prstGeom prst="rect">
+            <a:avLst/>
+          </a:prstGeom>
+          <a:noFill/>
+          <a:ln/>
+        </p:spPr>
+        <p:txBody>
+          <a:bodyPr wrap="square" rtlCol="0" anchor="ctr"/>
+          <a:lstStyle/>
+          <a:p>
+            <a:pPr indent="0" marL="0">
+              <a:buNone/>
+            </a:pPr>
+            <a:r>
+              <a:rPr lang="en-US" sz="950" b="1" dirty="0">
+                <a:solidFill>
+                  <a:srgbClr val="78350F"/>
+                </a:solidFill>
+                <a:latin typeface="Arial" pitchFamily="34" charset="0"/>
+                <a:ea typeface="Arial" pitchFamily="34" charset="-122"/>
+                <a:cs typeface="Arial" pitchFamily="34" charset="-120"/>
+              </a:rPr>
+              <a:t>HYBRID PHYSICS &amp; AI</a:t>
+            </a:r>
+            <a:endParaRPr lang="en-US" sz="950" dirty="0"/>
+          </a:p>
+        </p:txBody>
+      </p:sp>
+      <p:sp>
+        <p:nvSpPr>
+          <p:cNvPr id="27" name="Text 25"/>
+          <p:cNvSpPr/>
+          <p:nvPr/>
+        </p:nvSpPr>
+        <p:spPr>
+          <a:xfrm>
+            <a:off x="5175504" y="1984248"/>
+            <a:ext cx="1883664" cy="1325880"/>
+          </a:xfrm>
+          <a:prstGeom prst="rect">
+            <a:avLst/>
+          </a:prstGeom>
+          <a:noFill/>
+          <a:ln/>
+        </p:spPr>
+        <p:txBody>
+          <a:bodyPr wrap="square" rtlCol="0" anchor="ctr"/>
+          <a:lstStyle/>
+          <a:p>
+            <a:pPr indent="0" marL="0">
+              <a:buNone/>
+            </a:pPr>
+            <a:r>
+              <a:rPr lang="en-US" sz="800" dirty="0">
+                <a:solidFill>
+                  <a:srgbClr val="334155"/>
+                </a:solidFill>
+                <a:latin typeface="Calibri" pitchFamily="34" charset="0"/>
+                <a:ea typeface="Calibri" pitchFamily="34" charset="-122"/>
+                <a:cs typeface="Calibri" pitchFamily="34" charset="-120"/>
+              </a:rPr>
+              <a:t>• Darcy-Weisbach Hydraulics</a:t>
+            </a:r>
+            <a:endParaRPr lang="en-US" sz="800" dirty="0"/>
+          </a:p>
+          <a:p>
+            <a:pPr indent="0" marL="0">
+              <a:buNone/>
+            </a:pPr>
+            <a:r>
+              <a:rPr lang="en-US" sz="800" dirty="0">
+                <a:solidFill>
+                  <a:srgbClr val="334155"/>
+                </a:solidFill>
+                <a:latin typeface="Calibri" pitchFamily="34" charset="0"/>
+                <a:ea typeface="Calibri" pitchFamily="34" charset="-122"/>
+                <a:cs typeface="Calibri" pitchFamily="34" charset="-120"/>
+              </a:rPr>
+              <a:t>• ASTM D1250 Net Oil Solver</a:t>
+            </a:r>
+            <a:endParaRPr lang="en-US" sz="800" dirty="0"/>
+          </a:p>
+          <a:p>
+            <a:pPr indent="0" marL="0">
+              <a:buNone/>
+            </a:pPr>
+            <a:r>
+              <a:rPr lang="en-US" sz="800" dirty="0">
+                <a:solidFill>
+                  <a:srgbClr val="334155"/>
+                </a:solidFill>
+                <a:latin typeface="Calibri" pitchFamily="34" charset="0"/>
+                <a:ea typeface="Calibri" pitchFamily="34" charset="-122"/>
+                <a:cs typeface="Calibri" pitchFamily="34" charset="-120"/>
+              </a:rPr>
+              <a:t>• BS&amp;W Water-Cut Deconvolution</a:t>
+            </a:r>
+            <a:endParaRPr lang="en-US" sz="800" dirty="0"/>
+          </a:p>
+          <a:p>
+            <a:pPr indent="0" marL="0">
+              <a:buNone/>
+            </a:pPr>
+            <a:r>
+              <a:rPr lang="en-US" sz="800" dirty="0">
+                <a:solidFill>
+                  <a:srgbClr val="334155"/>
+                </a:solidFill>
+                <a:latin typeface="Calibri" pitchFamily="34" charset="0"/>
+                <a:ea typeface="Calibri" pitchFamily="34" charset="-122"/>
+                <a:cs typeface="Calibri" pitchFamily="34" charset="-120"/>
+              </a:rPr>
+              <a:t>• XGBoost Stick-Slip Detector</a:t>
+            </a:r>
+            <a:endParaRPr lang="en-US" sz="800" dirty="0"/>
+          </a:p>
+        </p:txBody>
+      </p:sp>
+      <p:sp>
+        <p:nvSpPr>
+          <p:cNvPr id="28" name="Shape 26"/>
+          <p:cNvSpPr/>
+          <p:nvPr/>
+        </p:nvSpPr>
+        <p:spPr>
+          <a:xfrm>
+            <a:off x="5129784" y="3401568"/>
+            <a:ext cx="1975104" cy="274320"/>
+          </a:xfrm>
+          <a:prstGeom prst="rect">
+            <a:avLst/>
+          </a:prstGeom>
+          <a:solidFill>
+            <a:srgbClr val="FFFFFF"/>
+          </a:solidFill>
+          <a:ln w="12700">
+            <a:solidFill>
+              <a:srgbClr val="FDE68A"/>
+            </a:solidFill>
+            <a:prstDash val="solid"/>
+          </a:ln>
+        </p:spPr>
+      </p:sp>
+      <p:sp>
+        <p:nvSpPr>
+          <p:cNvPr id="29" name="Text 27"/>
+          <p:cNvSpPr/>
+          <p:nvPr/>
+        </p:nvSpPr>
+        <p:spPr>
+          <a:xfrm>
+            <a:off x="5129784" y="3401568"/>
+            <a:ext cx="1975104" cy="274320"/>
+          </a:xfrm>
+          <a:prstGeom prst="rect">
+            <a:avLst/>
+          </a:prstGeom>
+          <a:noFill/>
+          <a:ln/>
+        </p:spPr>
+        <p:txBody>
+          <a:bodyPr wrap="square" rtlCol="0" anchor="ctr"/>
+          <a:lstStyle/>
+          <a:p>
+            <a:pPr algn="ctr" indent="0" marL="0">
+              <a:buNone/>
+            </a:pPr>
+            <a:r>
+              <a:rPr lang="en-US" sz="750" b="1" dirty="0">
+                <a:solidFill>
+                  <a:srgbClr val="78350F"/>
+                </a:solidFill>
+                <a:latin typeface="Arial" pitchFamily="34" charset="0"/>
+                <a:ea typeface="Arial" pitchFamily="34" charset="-122"/>
+                <a:cs typeface="Arial" pitchFamily="34" charset="-120"/>
+              </a:rPr>
+              <a:t>Physics Solutes &amp; Vectors ➔</a:t>
+            </a:r>
+            <a:endParaRPr lang="en-US" sz="750" dirty="0"/>
+          </a:p>
+        </p:txBody>
+      </p:sp>
+      <p:sp>
+        <p:nvSpPr>
+          <p:cNvPr id="30" name="Shape 28"/>
+          <p:cNvSpPr/>
+          <p:nvPr/>
+        </p:nvSpPr>
+        <p:spPr>
+          <a:xfrm>
+            <a:off x="7351776" y="1234440"/>
+            <a:ext cx="2066544" cy="2514600"/>
+          </a:xfrm>
+          <a:prstGeom prst="roundRect">
+            <a:avLst>
+              <a:gd name="adj" fmla="val 3540"/>
+            </a:avLst>
+          </a:prstGeom>
+          <a:solidFill>
+            <a:srgbClr val="FAF5FF"/>
+          </a:solidFill>
+          <a:ln w="19050">
+            <a:solidFill>
+              <a:srgbClr val="E9D5FF"/>
+            </a:solidFill>
+            <a:prstDash val="solid"/>
+          </a:ln>
+        </p:spPr>
+      </p:sp>
+      <p:sp>
+        <p:nvSpPr>
+          <p:cNvPr id="31" name="Shape 29"/>
+          <p:cNvSpPr/>
+          <p:nvPr/>
+        </p:nvSpPr>
+        <p:spPr>
+          <a:xfrm>
+            <a:off x="7443216" y="1325880"/>
+            <a:ext cx="594360" cy="228600"/>
+          </a:xfrm>
+          <a:prstGeom prst="roundRect">
+            <a:avLst>
+              <a:gd name="adj" fmla="val 20000"/>
+            </a:avLst>
+          </a:prstGeom>
+          <a:solidFill>
+            <a:srgbClr val="7C3AED"/>
+          </a:solidFill>
+          <a:ln/>
+        </p:spPr>
+      </p:sp>
+      <p:sp>
+        <p:nvSpPr>
+          <p:cNvPr id="32" name="Text 30"/>
+          <p:cNvSpPr/>
+          <p:nvPr/>
+        </p:nvSpPr>
+        <p:spPr>
+          <a:xfrm>
+            <a:off x="7443216" y="1325880"/>
+            <a:ext cx="594360" cy="228600"/>
+          </a:xfrm>
+          <a:prstGeom prst="rect">
+            <a:avLst/>
+          </a:prstGeom>
+          <a:noFill/>
+          <a:ln/>
+        </p:spPr>
+        <p:txBody>
+          <a:bodyPr wrap="square" rtlCol="0" anchor="ctr"/>
+          <a:lstStyle/>
+          <a:p>
+            <a:pPr algn="ctr" indent="0" marL="0">
+              <a:buNone/>
+            </a:pPr>
+            <a:r>
+              <a:rPr lang="en-US" sz="750" b="1" dirty="0">
+                <a:solidFill>
+                  <a:srgbClr val="FFFFFF"/>
+                </a:solidFill>
+                <a:latin typeface="Arial" pitchFamily="34" charset="0"/>
+                <a:ea typeface="Arial" pitchFamily="34" charset="-122"/>
+                <a:cs typeface="Arial" pitchFamily="34" charset="-120"/>
+              </a:rPr>
+              <a:t>STAGE 04</a:t>
+            </a:r>
+            <a:endParaRPr lang="en-US" sz="750" dirty="0"/>
+          </a:p>
+        </p:txBody>
+      </p:sp>
+      <p:sp>
+        <p:nvSpPr>
+          <p:cNvPr id="33" name="Text 31"/>
+          <p:cNvSpPr/>
+          <p:nvPr/>
+        </p:nvSpPr>
+        <p:spPr>
+          <a:xfrm>
+            <a:off x="8083296" y="1344168"/>
+            <a:ext cx="1243584" cy="201168"/>
+          </a:xfrm>
+          <a:prstGeom prst="rect">
+            <a:avLst/>
+          </a:prstGeom>
+          <a:noFill/>
+          <a:ln/>
+        </p:spPr>
+        <p:txBody>
+          <a:bodyPr wrap="square" rtlCol="0" anchor="ctr"/>
+          <a:lstStyle/>
+          <a:p>
+            <a:pPr indent="0" marL="0">
+              <a:buNone/>
+            </a:pPr>
+            <a:r>
+              <a:rPr lang="en-US" sz="700" b="1" dirty="0">
+                <a:solidFill>
+                  <a:srgbClr val="64748B"/>
+                </a:solidFill>
+                <a:latin typeface="Arial" pitchFamily="34" charset="0"/>
+                <a:ea typeface="Arial" pitchFamily="34" charset="-122"/>
+                <a:cs typeface="Arial" pitchFamily="34" charset="-120"/>
+              </a:rPr>
+              <a:t>REAL-TIME VISUALIZATION</a:t>
+            </a:r>
+            <a:endParaRPr lang="en-US" sz="700" dirty="0"/>
+          </a:p>
+        </p:txBody>
+      </p:sp>
+      <p:sp>
+        <p:nvSpPr>
+          <p:cNvPr id="34" name="Text 32"/>
+          <p:cNvSpPr/>
+          <p:nvPr/>
+        </p:nvSpPr>
+        <p:spPr>
+          <a:xfrm>
+            <a:off x="7443216" y="1581912"/>
+            <a:ext cx="1883664" cy="384048"/>
+          </a:xfrm>
+          <a:prstGeom prst="rect">
+            <a:avLst/>
+          </a:prstGeom>
+          <a:noFill/>
+          <a:ln/>
+        </p:spPr>
+        <p:txBody>
+          <a:bodyPr wrap="square" rtlCol="0" anchor="ctr"/>
+          <a:lstStyle/>
+          <a:p>
+            <a:pPr indent="0" marL="0">
+              <a:buNone/>
+            </a:pPr>
+            <a:r>
+              <a:rPr lang="en-US" sz="950" b="1" dirty="0">
+                <a:solidFill>
+                  <a:srgbClr val="4C1D95"/>
+                </a:solidFill>
+                <a:latin typeface="Arial" pitchFamily="34" charset="0"/>
+                <a:ea typeface="Arial" pitchFamily="34" charset="-122"/>
+                <a:cs typeface="Arial" pitchFamily="34" charset="-120"/>
+              </a:rPr>
+              <a:t>3D SPATIAL TWIN &amp; HCI</a:t>
+            </a:r>
+            <a:endParaRPr lang="en-US" sz="950" dirty="0"/>
+          </a:p>
+        </p:txBody>
+      </p:sp>
+      <p:sp>
+        <p:nvSpPr>
+          <p:cNvPr id="35" name="Text 33"/>
+          <p:cNvSpPr/>
+          <p:nvPr/>
+        </p:nvSpPr>
+        <p:spPr>
+          <a:xfrm>
+            <a:off x="7443216" y="1984248"/>
+            <a:ext cx="1883664" cy="1325880"/>
+          </a:xfrm>
+          <a:prstGeom prst="rect">
+            <a:avLst/>
+          </a:prstGeom>
+          <a:noFill/>
+          <a:ln/>
+        </p:spPr>
+        <p:txBody>
+          <a:bodyPr wrap="square" rtlCol="0" anchor="ctr"/>
+          <a:lstStyle/>
+          <a:p>
+            <a:pPr indent="0" marL="0">
+              <a:buNone/>
+            </a:pPr>
+            <a:r>
+              <a:rPr lang="en-US" sz="800" dirty="0">
+                <a:solidFill>
+                  <a:srgbClr val="334155"/>
+                </a:solidFill>
+                <a:latin typeface="Calibri" pitchFamily="34" charset="0"/>
+                <a:ea typeface="Calibri" pitchFamily="34" charset="-122"/>
+                <a:cs typeface="Calibri" pitchFamily="34" charset="-120"/>
+              </a:rPr>
+              <a:t>• Three.js / WebGL 3D Platform</a:t>
+            </a:r>
+            <a:endParaRPr lang="en-US" sz="800" dirty="0"/>
+          </a:p>
+          <a:p>
+            <a:pPr indent="0" marL="0">
+              <a:buNone/>
+            </a:pPr>
+            <a:r>
+              <a:rPr lang="en-US" sz="800" dirty="0">
+                <a:solidFill>
+                  <a:srgbClr val="334155"/>
+                </a:solidFill>
+                <a:latin typeface="Calibri" pitchFamily="34" charset="0"/>
+                <a:ea typeface="Calibri" pitchFamily="34" charset="-122"/>
+                <a:cs typeface="Calibri" pitchFamily="34" charset="-120"/>
+              </a:rPr>
+              <a:t>• 360° Orbit &amp; Explode View</a:t>
+            </a:r>
+            <a:endParaRPr lang="en-US" sz="800" dirty="0"/>
+          </a:p>
+          <a:p>
+            <a:pPr indent="0" marL="0">
+              <a:buNone/>
+            </a:pPr>
+            <a:r>
+              <a:rPr lang="en-US" sz="800" dirty="0">
+                <a:solidFill>
+                  <a:srgbClr val="334155"/>
+                </a:solidFill>
+                <a:latin typeface="Calibri" pitchFamily="34" charset="0"/>
+                <a:ea typeface="Calibri" pitchFamily="34" charset="-122"/>
+                <a:cs typeface="Calibri" pitchFamily="34" charset="-120"/>
+              </a:rPr>
+              <a:t>• Subsea Riser &amp; Flow Vectors</a:t>
+            </a:r>
+            <a:endParaRPr lang="en-US" sz="800" dirty="0"/>
+          </a:p>
+          <a:p>
+            <a:pPr indent="0" marL="0">
+              <a:buNone/>
+            </a:pPr>
+            <a:r>
+              <a:rPr lang="en-US" sz="800" dirty="0">
+                <a:solidFill>
+                  <a:srgbClr val="334155"/>
+                </a:solidFill>
+                <a:latin typeface="Calibri" pitchFamily="34" charset="0"/>
+                <a:ea typeface="Calibri" pitchFamily="34" charset="-122"/>
+                <a:cs typeface="Calibri" pitchFamily="34" charset="-120"/>
+              </a:rPr>
+              <a:t>• MediaPipe Hands &amp; Voice Copilot</a:t>
+            </a:r>
+            <a:endParaRPr lang="en-US" sz="800" dirty="0"/>
+          </a:p>
+        </p:txBody>
+      </p:sp>
+      <p:sp>
+        <p:nvSpPr>
+          <p:cNvPr id="36" name="Shape 34"/>
+          <p:cNvSpPr/>
+          <p:nvPr/>
+        </p:nvSpPr>
+        <p:spPr>
+          <a:xfrm>
+            <a:off x="7397496" y="3401568"/>
+            <a:ext cx="1975104" cy="274320"/>
+          </a:xfrm>
+          <a:prstGeom prst="rect">
+            <a:avLst/>
+          </a:prstGeom>
+          <a:solidFill>
+            <a:srgbClr val="FFFFFF"/>
+          </a:solidFill>
+          <a:ln w="12700">
+            <a:solidFill>
+              <a:srgbClr val="E9D5FF"/>
+            </a:solidFill>
+            <a:prstDash val="solid"/>
+          </a:ln>
+        </p:spPr>
+      </p:sp>
+      <p:sp>
+        <p:nvSpPr>
+          <p:cNvPr id="37" name="Text 35"/>
+          <p:cNvSpPr/>
+          <p:nvPr/>
+        </p:nvSpPr>
+        <p:spPr>
+          <a:xfrm>
+            <a:off x="7397496" y="3401568"/>
+            <a:ext cx="1975104" cy="274320"/>
+          </a:xfrm>
+          <a:prstGeom prst="rect">
+            <a:avLst/>
+          </a:prstGeom>
+          <a:noFill/>
+          <a:ln/>
+        </p:spPr>
+        <p:txBody>
+          <a:bodyPr wrap="square" rtlCol="0" anchor="ctr"/>
+          <a:lstStyle/>
+          <a:p>
+            <a:pPr algn="ctr" indent="0" marL="0">
+              <a:buNone/>
+            </a:pPr>
+            <a:r>
+              <a:rPr lang="en-US" sz="750" b="1" dirty="0">
+                <a:solidFill>
+                  <a:srgbClr val="4C1D95"/>
+                </a:solidFill>
+                <a:latin typeface="Arial" pitchFamily="34" charset="0"/>
+                <a:ea typeface="Arial" pitchFamily="34" charset="-122"/>
+                <a:cs typeface="Arial" pitchFamily="34" charset="-120"/>
+              </a:rPr>
+              <a:t>Supervisory Dispatch ➔</a:t>
+            </a:r>
+            <a:endParaRPr lang="en-US" sz="750" dirty="0"/>
+          </a:p>
+        </p:txBody>
+      </p:sp>
+      <p:sp>
+        <p:nvSpPr>
+          <p:cNvPr id="38" name="Shape 36"/>
+          <p:cNvSpPr/>
+          <p:nvPr/>
+        </p:nvSpPr>
+        <p:spPr>
+          <a:xfrm>
+            <a:off x="9619488" y="1234440"/>
+            <a:ext cx="2066544" cy="2514600"/>
+          </a:xfrm>
+          <a:prstGeom prst="roundRect">
+            <a:avLst>
+              <a:gd name="adj" fmla="val 3540"/>
+            </a:avLst>
+          </a:prstGeom>
+          <a:solidFill>
+            <a:srgbClr val="FDF2F8"/>
+          </a:solidFill>
+          <a:ln w="19050">
+            <a:solidFill>
+              <a:srgbClr val="FBCFE8"/>
+            </a:solidFill>
+            <a:prstDash val="solid"/>
+          </a:ln>
+        </p:spPr>
+      </p:sp>
+      <p:sp>
+        <p:nvSpPr>
+          <p:cNvPr id="39" name="Shape 37"/>
+          <p:cNvSpPr/>
+          <p:nvPr/>
+        </p:nvSpPr>
+        <p:spPr>
+          <a:xfrm>
+            <a:off x="9710928" y="1325880"/>
+            <a:ext cx="594360" cy="228600"/>
+          </a:xfrm>
+          <a:prstGeom prst="roundRect">
+            <a:avLst>
+              <a:gd name="adj" fmla="val 20000"/>
+            </a:avLst>
+          </a:prstGeom>
+          <a:solidFill>
+            <a:srgbClr val="DB2777"/>
+          </a:solidFill>
+          <a:ln/>
+        </p:spPr>
+      </p:sp>
+      <p:sp>
+        <p:nvSpPr>
+          <p:cNvPr id="40" name="Text 38"/>
+          <p:cNvSpPr/>
+          <p:nvPr/>
+        </p:nvSpPr>
+        <p:spPr>
+          <a:xfrm>
+            <a:off x="9710928" y="1325880"/>
+            <a:ext cx="594360" cy="228600"/>
+          </a:xfrm>
+          <a:prstGeom prst="rect">
+            <a:avLst/>
+          </a:prstGeom>
+          <a:noFill/>
+          <a:ln/>
+        </p:spPr>
+        <p:txBody>
+          <a:bodyPr wrap="square" rtlCol="0" anchor="ctr"/>
+          <a:lstStyle/>
+          <a:p>
+            <a:pPr algn="ctr" indent="0" marL="0">
+              <a:buNone/>
+            </a:pPr>
+            <a:r>
+              <a:rPr lang="en-US" sz="750" b="1" dirty="0">
+                <a:solidFill>
+                  <a:srgbClr val="FFFFFF"/>
+                </a:solidFill>
+                <a:latin typeface="Arial" pitchFamily="34" charset="0"/>
+                <a:ea typeface="Arial" pitchFamily="34" charset="-122"/>
+                <a:cs typeface="Arial" pitchFamily="34" charset="-120"/>
+              </a:rPr>
+              <a:t>STAGE 05</a:t>
+            </a:r>
+            <a:endParaRPr lang="en-US" sz="750" dirty="0"/>
+          </a:p>
+        </p:txBody>
+      </p:sp>
+      <p:sp>
+        <p:nvSpPr>
+          <p:cNvPr id="41" name="Text 39"/>
+          <p:cNvSpPr/>
+          <p:nvPr/>
+        </p:nvSpPr>
+        <p:spPr>
+          <a:xfrm>
+            <a:off x="10351008" y="1344168"/>
+            <a:ext cx="1243584" cy="201168"/>
+          </a:xfrm>
+          <a:prstGeom prst="rect">
+            <a:avLst/>
+          </a:prstGeom>
+          <a:noFill/>
+          <a:ln/>
+        </p:spPr>
+        <p:txBody>
+          <a:bodyPr wrap="square" rtlCol="0" anchor="ctr"/>
+          <a:lstStyle/>
+          <a:p>
+            <a:pPr indent="0" marL="0">
+              <a:buNone/>
+            </a:pPr>
+            <a:r>
+              <a:rPr lang="en-US" sz="700" b="1" dirty="0">
+                <a:solidFill>
+                  <a:srgbClr val="64748B"/>
+                </a:solidFill>
+                <a:latin typeface="Arial" pitchFamily="34" charset="0"/>
+                <a:ea typeface="Arial" pitchFamily="34" charset="-122"/>
+                <a:cs typeface="Arial" pitchFamily="34" charset="-120"/>
+              </a:rPr>
+              <a:t>GOVERNANCE &amp; ACTION</a:t>
+            </a:r>
+            <a:endParaRPr lang="en-US" sz="700" dirty="0"/>
+          </a:p>
+        </p:txBody>
+      </p:sp>
+      <p:sp>
+        <p:nvSpPr>
+          <p:cNvPr id="42" name="Text 40"/>
+          <p:cNvSpPr/>
+          <p:nvPr/>
+        </p:nvSpPr>
+        <p:spPr>
+          <a:xfrm>
+            <a:off x="9710928" y="1581912"/>
+            <a:ext cx="1883664" cy="384048"/>
+          </a:xfrm>
+          <a:prstGeom prst="rect">
+            <a:avLst/>
+          </a:prstGeom>
+          <a:noFill/>
+          <a:ln/>
+        </p:spPr>
+        <p:txBody>
+          <a:bodyPr wrap="square" rtlCol="0" anchor="ctr"/>
+          <a:lstStyle/>
+          <a:p>
+            <a:pPr indent="0" marL="0">
+              <a:buNone/>
+            </a:pPr>
+            <a:r>
+              <a:rPr lang="en-US" sz="950" b="1" dirty="0">
+                <a:solidFill>
+                  <a:srgbClr val="831843"/>
+                </a:solidFill>
+                <a:latin typeface="Arial" pitchFamily="34" charset="0"/>
+                <a:ea typeface="Arial" pitchFamily="34" charset="-122"/>
+                <a:cs typeface="Arial" pitchFamily="34" charset="-120"/>
+              </a:rPr>
+              <a:t>MIDNIGHT SETTLEMENT</a:t>
+            </a:r>
+            <a:endParaRPr lang="en-US" sz="950" dirty="0"/>
+          </a:p>
+        </p:txBody>
+      </p:sp>
+      <p:sp>
+        <p:nvSpPr>
+          <p:cNvPr id="43" name="Text 41"/>
+          <p:cNvSpPr/>
+          <p:nvPr/>
+        </p:nvSpPr>
+        <p:spPr>
+          <a:xfrm>
+            <a:off x="9710928" y="1984248"/>
+            <a:ext cx="1883664" cy="1325880"/>
+          </a:xfrm>
+          <a:prstGeom prst="rect">
+            <a:avLst/>
+          </a:prstGeom>
+          <a:noFill/>
+          <a:ln/>
+        </p:spPr>
+        <p:txBody>
+          <a:bodyPr wrap="square" rtlCol="0" anchor="ctr"/>
+          <a:lstStyle/>
+          <a:p>
+            <a:pPr indent="0" marL="0">
+              <a:buNone/>
+            </a:pPr>
+            <a:r>
+              <a:rPr lang="en-US" sz="800" dirty="0">
+                <a:solidFill>
+                  <a:srgbClr val="334155"/>
+                </a:solidFill>
+                <a:latin typeface="Calibri" pitchFamily="34" charset="0"/>
+                <a:ea typeface="Calibri" pitchFamily="34" charset="-122"/>
+                <a:cs typeface="Calibri" pitchFamily="34" charset="-120"/>
+              </a:rPr>
+              <a:t>• Automated 12:00 AM EOD Audit</a:t>
+            </a:r>
+            <a:endParaRPr lang="en-US" sz="800" dirty="0"/>
+          </a:p>
+          <a:p>
+            <a:pPr indent="0" marL="0">
+              <a:buNone/>
+            </a:pPr>
+            <a:r>
+              <a:rPr lang="en-US" sz="800" dirty="0">
+                <a:solidFill>
+                  <a:srgbClr val="334155"/>
+                </a:solidFill>
+                <a:latin typeface="Calibri" pitchFamily="34" charset="0"/>
+                <a:ea typeface="Calibri" pitchFamily="34" charset="-122"/>
+                <a:cs typeface="Calibri" pitchFamily="34" charset="-120"/>
+              </a:rPr>
+              <a:t>• Gross vs Net Barrels Accounting</a:t>
+            </a:r>
+            <a:endParaRPr lang="en-US" sz="800" dirty="0"/>
+          </a:p>
+          <a:p>
+            <a:pPr indent="0" marL="0">
+              <a:buNone/>
+            </a:pPr>
+            <a:r>
+              <a:rPr lang="en-US" sz="800" dirty="0">
+                <a:solidFill>
+                  <a:srgbClr val="334155"/>
+                </a:solidFill>
+                <a:latin typeface="Calibri" pitchFamily="34" charset="0"/>
+                <a:ea typeface="Calibri" pitchFamily="34" charset="-122"/>
+                <a:cs typeface="Calibri" pitchFamily="34" charset="-120"/>
+              </a:rPr>
+              <a:t>• DGH Regulatory Compliance</a:t>
+            </a:r>
+            <a:endParaRPr lang="en-US" sz="800" dirty="0"/>
+          </a:p>
+          <a:p>
+            <a:pPr indent="0" marL="0">
+              <a:buNone/>
+            </a:pPr>
+            <a:r>
+              <a:rPr lang="en-US" sz="800" dirty="0">
+                <a:solidFill>
+                  <a:srgbClr val="334155"/>
+                </a:solidFill>
+                <a:latin typeface="Calibri" pitchFamily="34" charset="0"/>
+                <a:ea typeface="Calibri" pitchFamily="34" charset="-122"/>
+                <a:cs typeface="Calibri" pitchFamily="34" charset="-120"/>
+              </a:rPr>
+              <a:t>• Closed-Loop Throttle Interlock</a:t>
+            </a:r>
+            <a:endParaRPr lang="en-US" sz="800" dirty="0"/>
+          </a:p>
+        </p:txBody>
+      </p:sp>
+      <p:sp>
+        <p:nvSpPr>
+          <p:cNvPr id="44" name="Shape 42"/>
+          <p:cNvSpPr/>
+          <p:nvPr/>
+        </p:nvSpPr>
+        <p:spPr>
+          <a:xfrm>
+            <a:off x="9665208" y="3401568"/>
+            <a:ext cx="1975104" cy="274320"/>
+          </a:xfrm>
+          <a:prstGeom prst="rect">
+            <a:avLst/>
+          </a:prstGeom>
+          <a:solidFill>
+            <a:srgbClr val="FFFFFF"/>
+          </a:solidFill>
+          <a:ln w="12700">
+            <a:solidFill>
+              <a:srgbClr val="FBCFE8"/>
+            </a:solidFill>
+            <a:prstDash val="solid"/>
+          </a:ln>
+        </p:spPr>
+      </p:sp>
+      <p:sp>
+        <p:nvSpPr>
+          <p:cNvPr id="45" name="Text 43"/>
+          <p:cNvSpPr/>
+          <p:nvPr/>
+        </p:nvSpPr>
+        <p:spPr>
+          <a:xfrm>
+            <a:off x="9665208" y="3401568"/>
+            <a:ext cx="1975104" cy="274320"/>
+          </a:xfrm>
+          <a:prstGeom prst="rect">
+            <a:avLst/>
+          </a:prstGeom>
+          <a:noFill/>
+          <a:ln/>
+        </p:spPr>
+        <p:txBody>
+          <a:bodyPr wrap="square" rtlCol="0" anchor="ctr"/>
+          <a:lstStyle/>
+          <a:p>
+            <a:pPr algn="ctr" indent="0" marL="0">
+              <a:buNone/>
+            </a:pPr>
+            <a:r>
+              <a:rPr lang="en-US" sz="750" b="1" dirty="0">
+                <a:solidFill>
+                  <a:srgbClr val="831843"/>
+                </a:solidFill>
+                <a:latin typeface="Arial" pitchFamily="34" charset="0"/>
+                <a:ea typeface="Arial" pitchFamily="34" charset="-122"/>
+                <a:cs typeface="Arial" pitchFamily="34" charset="-120"/>
+              </a:rPr>
+              <a:t>Closed-Loop Actuation ✔</a:t>
+            </a:r>
+            <a:endParaRPr lang="en-US" sz="750" dirty="0"/>
+          </a:p>
+        </p:txBody>
+      </p:sp>
+      <p:sp>
+        <p:nvSpPr>
+          <p:cNvPr id="46" name="Shape 44"/>
+          <p:cNvSpPr/>
+          <p:nvPr/>
+        </p:nvSpPr>
+        <p:spPr>
+          <a:xfrm>
+            <a:off x="548640" y="3886200"/>
+            <a:ext cx="5852160" cy="2240280"/>
+          </a:xfrm>
+          <a:prstGeom prst="roundRect">
+            <a:avLst>
+              <a:gd name="adj" fmla="val 3265"/>
+            </a:avLst>
+          </a:prstGeom>
+          <a:solidFill>
+            <a:srgbClr val="F8FAFC"/>
+          </a:solidFill>
+          <a:ln w="12700">
+            <a:solidFill>
+              <a:srgbClr val="E2E8F0"/>
+            </a:solidFill>
+            <a:prstDash val="solid"/>
+          </a:ln>
+        </p:spPr>
+      </p:sp>
+      <p:sp>
+        <p:nvSpPr>
+          <p:cNvPr id="47" name="Text 45"/>
+          <p:cNvSpPr/>
+          <p:nvPr/>
+        </p:nvSpPr>
+        <p:spPr>
+          <a:xfrm>
+            <a:off x="731520" y="3977640"/>
+            <a:ext cx="5486400" cy="256032"/>
           </a:xfrm>
           <a:prstGeom prst="rect">
             <a:avLst/>
@@ -2747,19 +4127,58 @@
             <a:r>
               <a:rPr lang="en-US" sz="1050" b="1" dirty="0">
                 <a:solidFill>
+                  <a:srgbClr val="1E3A8A"/>
+                </a:solidFill>
+                <a:latin typeface="Arial" pitchFamily="34" charset="0"/>
+                <a:ea typeface="Arial" pitchFamily="34" charset="-122"/>
+                <a:cs typeface="Arial" pitchFamily="34" charset="-120"/>
+              </a:rPr>
+              <a:t>CORE TECHNOLOGY STACK &amp; PROTOCOL CONNECTIONS</a:t>
+            </a:r>
+            <a:endParaRPr lang="en-US" sz="1050" dirty="0"/>
+          </a:p>
+        </p:txBody>
+      </p:sp>
+      <p:sp>
+        <p:nvSpPr>
+          <p:cNvPr id="48" name="Text 46"/>
+          <p:cNvSpPr/>
+          <p:nvPr/>
+        </p:nvSpPr>
+        <p:spPr>
+          <a:xfrm>
+            <a:off x="731520" y="4233672"/>
+            <a:ext cx="5486400" cy="1783080"/>
+          </a:xfrm>
+          <a:prstGeom prst="rect">
+            <a:avLst/>
+          </a:prstGeom>
+          <a:noFill/>
+          <a:ln/>
+        </p:spPr>
+        <p:txBody>
+          <a:bodyPr wrap="square" rtlCol="0" anchor="ctr"/>
+          <a:lstStyle/>
+          <a:p>
+            <a:pPr indent="0" marL="0">
+              <a:buNone/>
+            </a:pPr>
+            <a:r>
+              <a:rPr lang="en-US" sz="900" b="1" dirty="0">
+                <a:solidFill>
                   <a:srgbClr val="0F172A"/>
                 </a:solidFill>
                 <a:latin typeface="Calibri" pitchFamily="34" charset="0"/>
                 <a:ea typeface="Calibri" pitchFamily="34" charset="-122"/>
                 <a:cs typeface="Calibri" pitchFamily="34" charset="-120"/>
               </a:rPr>
-              <a:t>1. Multi-Rate Ingestion: </a:t>
-            </a:r>
-            <a:pPr indent="0" marL="0">
-              <a:buNone/>
-            </a:pPr>
-            <a:r>
-              <a:rPr lang="en-US" sz="1050" dirty="0">
+              <a:t>• Edge SCADA Protocols: </a:t>
+            </a:r>
+            <a:pPr indent="0" marL="0">
+              <a:buNone/>
+            </a:pPr>
+            <a:r>
+              <a:rPr lang="en-US" sz="900" dirty="0">
                 <a:solidFill>
                   <a:srgbClr val="334155"/>
                 </a:solidFill>
@@ -2767,14 +4186,14 @@
                 <a:ea typeface="Calibri" pitchFamily="34" charset="-122"/>
                 <a:cs typeface="Calibri" pitchFamily="34" charset="-120"/>
               </a:rPr>
-              <a:t>50.0 Hz subsea telemetry stream fed into edge Kalman filters.
+              <a:t>OPC-UA, Modbus RTU/TCP, WITSML, Serial USB WebGateway (50Hz / 20ms).
 </a:t>
             </a:r>
             <a:pPr indent="0" marL="0">
               <a:buNone/>
             </a:pPr>
             <a:r>
-              <a:rPr lang="en-US" sz="1050" b="1" dirty="0">
+              <a:rPr lang="en-US" sz="900" b="1" dirty="0">
                 <a:solidFill>
                   <a:srgbClr val="0F172A"/>
                 </a:solidFill>
@@ -2782,13 +4201,13 @@
                 <a:ea typeface="Calibri" pitchFamily="34" charset="-122"/>
                 <a:cs typeface="Calibri" pitchFamily="34" charset="-120"/>
               </a:rPr>
-              <a:t>2. Physics Deconvolution: </a:t>
-            </a:r>
-            <a:pPr indent="0" marL="0">
-              <a:buNone/>
-            </a:pPr>
-            <a:r>
-              <a:rPr lang="en-US" sz="1050" dirty="0">
+              <a:t>• Physics &amp; Standards: </a:t>
+            </a:r>
+            <a:pPr indent="0" marL="0">
+              <a:buNone/>
+            </a:pPr>
+            <a:r>
+              <a:rPr lang="en-US" sz="900" dirty="0">
                 <a:solidFill>
                   <a:srgbClr val="334155"/>
                 </a:solidFill>
@@ -2796,14 +4215,14 @@
                 <a:ea typeface="Calibri" pitchFamily="34" charset="-122"/>
                 <a:cs typeface="Calibri" pitchFamily="34" charset="-120"/>
               </a:rPr>
-              <a:t>Equations solve multiphase cut and ASTM temperature/pressure corrections.
+              <a:t>ASTM D1250 / API MPMS 11.1 (CTL/CPL), Darcy-Weisbach multiphase pressure gradients.
 </a:t>
             </a:r>
             <a:pPr indent="0" marL="0">
               <a:buNone/>
             </a:pPr>
             <a:r>
-              <a:rPr lang="en-US" sz="1050" b="1" dirty="0">
+              <a:rPr lang="en-US" sz="900" b="1" dirty="0">
                 <a:solidFill>
                   <a:srgbClr val="0F172A"/>
                 </a:solidFill>
@@ -2811,13 +4230,13 @@
                 <a:ea typeface="Calibri" pitchFamily="34" charset="-122"/>
                 <a:cs typeface="Calibri" pitchFamily="34" charset="-120"/>
               </a:rPr>
-              <a:t>3. 3D Spatial Synchronization: </a:t>
-            </a:r>
-            <a:pPr indent="0" marL="0">
-              <a:buNone/>
-            </a:pPr>
-            <a:r>
-              <a:rPr lang="en-US" sz="1050" dirty="0">
+              <a:t>• AI &amp; Estimators: </a:t>
+            </a:r>
+            <a:pPr indent="0" marL="0">
+              <a:buNone/>
+            </a:pPr>
+            <a:r>
+              <a:rPr lang="en-US" sz="900" dirty="0">
                 <a:solidFill>
                   <a:srgbClr val="334155"/>
                 </a:solidFill>
@@ -2825,14 +4244,14 @@
                 <a:ea typeface="Calibri" pitchFamily="34" charset="-122"/>
                 <a:cs typeface="Calibri" pitchFamily="34" charset="-120"/>
               </a:rPr>
-              <a:t>WebGL digital twin renders animated flows, riser stresses, and PDC rotation.
+              <a:t>Discrete 1D Kalman state estimators, XGBoost stick-slip anomaly classifiers.
 </a:t>
             </a:r>
             <a:pPr indent="0" marL="0">
               <a:buNone/>
             </a:pPr>
             <a:r>
-              <a:rPr lang="en-US" sz="1050" b="1" dirty="0">
+              <a:rPr lang="en-US" sz="900" b="1" dirty="0">
                 <a:solidFill>
                   <a:srgbClr val="0F172A"/>
                 </a:solidFill>
@@ -2840,13 +4259,13 @@
                 <a:ea typeface="Calibri" pitchFamily="34" charset="-122"/>
                 <a:cs typeface="Calibri" pitchFamily="34" charset="-120"/>
               </a:rPr>
-              <a:t>4. Midnight EOD Settlement: </a:t>
-            </a:r>
-            <a:pPr indent="0" marL="0">
-              <a:buNone/>
-            </a:pPr>
-            <a:r>
-              <a:rPr lang="en-US" sz="1050" dirty="0">
+              <a:t>• 3D Spatial Interface: </a:t>
+            </a:r>
+            <a:pPr indent="0" marL="0">
+              <a:buNone/>
+            </a:pPr>
+            <a:r>
+              <a:rPr lang="en-US" sz="900" dirty="0">
                 <a:solidFill>
                   <a:srgbClr val="334155"/>
                 </a:solidFill>
@@ -2854,15 +4273,44 @@
                 <a:ea typeface="Calibri" pitchFamily="34" charset="-122"/>
                 <a:cs typeface="Calibri" pitchFamily="34" charset="-120"/>
               </a:rPr>
-              <a:t>Automated 12:00 AM daemon seals certified daily DGH compliance ledgers.</a:t>
-            </a:r>
-            <a:endParaRPr lang="en-US" sz="1050" dirty="0"/>
+              <a:t>Three.js / WebGL with 360° orbit, explode view, MediaPipe hands &amp; Jarvis voice.
+</a:t>
+            </a:r>
+            <a:pPr indent="0" marL="0">
+              <a:buNone/>
+            </a:pPr>
+            <a:r>
+              <a:rPr lang="en-US" sz="900" b="1" dirty="0">
+                <a:solidFill>
+                  <a:srgbClr val="0F172A"/>
+                </a:solidFill>
+                <a:latin typeface="Calibri" pitchFamily="34" charset="0"/>
+                <a:ea typeface="Calibri" pitchFamily="34" charset="-122"/>
+                <a:cs typeface="Calibri" pitchFamily="34" charset="-120"/>
+              </a:rPr>
+              <a:t>• Storage &amp; Settlement: </a:t>
+            </a:r>
+            <a:pPr indent="0" marL="0">
+              <a:buNone/>
+            </a:pPr>
+            <a:r>
+              <a:rPr lang="en-US" sz="900" dirty="0">
+                <a:solidFill>
+                  <a:srgbClr val="334155"/>
+                </a:solidFill>
+                <a:latin typeface="Calibri" pitchFamily="34" charset="0"/>
+                <a:ea typeface="Calibri" pitchFamily="34" charset="-122"/>
+                <a:cs typeface="Calibri" pitchFamily="34" charset="-120"/>
+              </a:rPr>
+              <a:t>180-day local time-series ledger with automated 12:00 Midnight DGH regulatory audit.</a:t>
+            </a:r>
+            <a:endParaRPr lang="en-US" sz="900" dirty="0"/>
           </a:p>
         </p:txBody>
       </p:sp>
       <p:pic>
         <p:nvPicPr>
-          <p:cNvPr id="10" name="Image 0" descr="E:\Digital Twin\public\presentation\rig_diorama_colored_1789147250513.jpg">    </p:cNvPr>
+          <p:cNvPr id="49" name="Image 0" descr="E:\Digital Twin\public\presentation\rig_diorama_colored_1789147250513.jpg">    </p:cNvPr>
           <p:cNvPicPr>
             <a:picLocks noChangeAspect="1"/>
           </p:cNvPicPr>
@@ -2876,8 +4324,8 @@
         </p:blipFill>
         <p:spPr>
           <a:xfrm>
-            <a:off x="6492240" y="1280160"/>
-            <a:ext cx="5120640" cy="2377440"/>
+            <a:off x="6583680" y="3886200"/>
+            <a:ext cx="2468880" cy="2240280"/>
           </a:xfrm>
           <a:prstGeom prst="rect">
             <a:avLst/>
@@ -2886,7 +4334,7 @@
       </p:pic>
       <p:pic>
         <p:nvPicPr>
-          <p:cNvPr id="11" name="Image 1" descr="E:\Digital Twin\public\presentation\hologram_digital_twin_1789148609789.jpg">    </p:cNvPr>
+          <p:cNvPr id="50" name="Image 1" descr="E:\Digital Twin\public\presentation\hologram_digital_twin_1789148609789.jpg">    </p:cNvPr>
           <p:cNvPicPr>
             <a:picLocks noChangeAspect="1"/>
           </p:cNvPicPr>
@@ -2900,8 +4348,8 @@
         </p:blipFill>
         <p:spPr>
           <a:xfrm>
-            <a:off x="6492240" y="3794760"/>
-            <a:ext cx="5120640" cy="2377440"/>
+            <a:off x="9189720" y="3886200"/>
+            <a:ext cx="2468880" cy="2240280"/>
           </a:xfrm>
           <a:prstGeom prst="rect">
             <a:avLst/>

</xml_diff>